<commit_message>
docs: align presentation credit and workflow wording
</commit_message>
<xml_diff>
--- a/presentations/OWERF_Project_Presentation.pptx
+++ b/presentations/OWERF_Project_Presentation.pptx
@@ -3154,12 +3154,12 @@
               <a:buNone/>
             </a:pPr>
             <a:r>
-              <a:rPr lang="en-US" sz="1400" dirty="0">
-                <a:solidFill>
-                  <a:schemeClr val="tx1"/>
-                </a:solidFill>
-              </a:rPr>
-              <a:t>B.Tech deep-learning project</a:t>
+              <a:rPr lang="en-US" sz="1100" dirty="0">
+                <a:solidFill>
+                  <a:schemeClr val="tx1"/>
+                </a:solidFill>
+              </a:rPr>
+              <a:t>Ishant Pant | Research Supervisor: Dr. Sandeep Gupta</a:t>
             </a:r>
             <a:endParaRPr lang="en-US" sz="1400" dirty="0"/>
           </a:p>
@@ -4423,7 +4423,7 @@
                   <a:schemeClr val="tx1"/>
                 </a:solidFill>
               </a:rPr>
-              <a:t>How it works in real life</a:t>
+              <a:t>Illustrative operational workflow</a:t>
             </a:r>
             <a:endParaRPr lang="en-US" sz="3400" dirty="0"/>
           </a:p>

</xml_diff>

<commit_message>
docs: add presentation author credit and clarify proposed workflow
Credit Ishant Pant as the sole student author and Dr. Sandeep Gupta as research supervisor on the presentation cover. Label the operational flow as illustrative.
</commit_message>
<xml_diff>
--- a/presentations/OWERF_Project_Presentation.pptx
+++ b/presentations/OWERF_Project_Presentation.pptx
@@ -3154,12 +3154,12 @@
               <a:buNone/>
             </a:pPr>
             <a:r>
-              <a:rPr lang="en-US" sz="1400" dirty="0">
-                <a:solidFill>
-                  <a:schemeClr val="tx1"/>
-                </a:solidFill>
-              </a:rPr>
-              <a:t>B.Tech deep-learning project</a:t>
+              <a:rPr lang="en-US" sz="1100" dirty="0">
+                <a:solidFill>
+                  <a:schemeClr val="tx1"/>
+                </a:solidFill>
+              </a:rPr>
+              <a:t>Ishant Pant | Research Supervisor: Dr. Sandeep Gupta</a:t>
             </a:r>
             <a:endParaRPr lang="en-US" sz="1400" dirty="0"/>
           </a:p>
@@ -4423,7 +4423,7 @@
                   <a:schemeClr val="tx1"/>
                 </a:solidFill>
               </a:rPr>
-              <a:t>How it works in real life</a:t>
+              <a:t>Illustrative operational workflow</a:t>
             </a:r>
             <a:endParaRPr lang="en-US" sz="3400" dirty="0"/>
           </a:p>

</xml_diff>